<commit_message>
Update deck with properly-sized slide 7 demo screenshot
Co-Authored-By: Claude Sonnet 5 <noreply@anthropic.com>
</commit_message>
<xml_diff>
--- a/presentation/prove-me-wrong-deck.pptx
+++ b/presentation/prove-me-wrong-deck.pptx
@@ -4067,8 +4067,8 @@
         </p:blipFill>
         <p:spPr>
           <a:xfrm>
-            <a:off x="2194560" y="1600200"/>
-            <a:ext cx="7772400" cy="4892040"/>
+            <a:off x="4343400" y="1600200"/>
+            <a:ext cx="3474720" cy="4846320"/>
           </a:xfrm>
           <a:prstGeom prst="rect">
             <a:avLst/>

</xml_diff>

<commit_message>
Fix blurry/squeezed images on slides 1 and 10
Root cause: slides 1 and 10 forced landscape screenshots (1.93 aspect,
mostly empty margins) into tall portrait side-panels using 'cover'
sizing - this cropped and upscaled them heavily, causing blur.

Fixed by: (1) tightly cropping the cover and summary screenshots to just
the actual card content, same treatment as the earlier slide 7 fix, and
(2) switching from 'cover' to 'contain' sizing so nothing gets force-
cropped or upscaled. Slide 10 also got a layout change since the
summary card is naturally landscape-shaped, not suited to the tall
side-panel format the other slides use.

Note: still could not render visual QA images in this environment (no
LibreOffice) - please do another visual pass and flag anything else.

Co-Authored-By: Claude Sonnet 5 <noreply@anthropic.com>
</commit_message>
<xml_diff>
--- a/presentation/prove-me-wrong-deck.pptx
+++ b/presentation/prove-me-wrong-deck.pptx
@@ -1921,9 +1921,87 @@
           <a:chExt cx="0" cy="0"/>
         </a:xfrm>
       </p:grpSpPr>
+      <p:sp>
+        <p:nvSpPr>
+          <p:cNvPr id="2" name="Text 0"/>
+          <p:cNvSpPr txBox="1"/>
+          <p:nvPr/>
+        </p:nvSpPr>
+        <p:spPr>
+          <a:xfrm>
+            <a:off x="640080" y="822960"/>
+            <a:ext cx="7315200" cy="914400"/>
+          </a:xfrm>
+          <a:prstGeom prst="rect">
+            <a:avLst/>
+          </a:prstGeom>
+          <a:noFill/>
+          <a:ln/>
+        </p:spPr>
+        <p:txBody>
+          <a:bodyPr wrap="square" lIns="0" tIns="0" rIns="0" bIns="0" rtlCol="0" anchor="ctr"/>
+          <a:lstStyle/>
+          <a:p>
+            <a:pPr indent="0" marL="0">
+              <a:buNone/>
+            </a:pPr>
+            <a:r>
+              <a:rPr lang="en-US" sz="4000" b="1" dirty="0">
+                <a:solidFill>
+                  <a:srgbClr val="4FD3C4"/>
+                </a:solidFill>
+                <a:latin typeface="Century Schoolbook" pitchFamily="34" charset="0"/>
+                <a:ea typeface="Century Schoolbook" pitchFamily="34" charset="-122"/>
+                <a:cs typeface="Century Schoolbook" pitchFamily="34" charset="-120"/>
+              </a:rPr>
+              <a:t>Prove Me Wrong</a:t>
+            </a:r>
+            <a:endParaRPr lang="en-US" sz="4000" dirty="0"/>
+          </a:p>
+        </p:txBody>
+      </p:sp>
+      <p:sp>
+        <p:nvSpPr>
+          <p:cNvPr id="3" name="Text 1"/>
+          <p:cNvSpPr txBox="1"/>
+          <p:nvPr/>
+        </p:nvSpPr>
+        <p:spPr>
+          <a:xfrm>
+            <a:off x="640080" y="1691640"/>
+            <a:ext cx="7315200" cy="822960"/>
+          </a:xfrm>
+          <a:prstGeom prst="rect">
+            <a:avLst/>
+          </a:prstGeom>
+          <a:noFill/>
+          <a:ln/>
+        </p:spPr>
+        <p:txBody>
+          <a:bodyPr wrap="square" lIns="0" tIns="0" rIns="0" bIns="0" rtlCol="0" anchor="ctr"/>
+          <a:lstStyle/>
+          <a:p>
+            <a:pPr indent="0" marL="0">
+              <a:buNone/>
+            </a:pPr>
+            <a:r>
+              <a:rPr lang="en-US" sz="1600" dirty="0">
+                <a:solidFill>
+                  <a:srgbClr val="A49D8B"/>
+                </a:solidFill>
+                <a:latin typeface="Calibri" pitchFamily="34" charset="0"/>
+                <a:ea typeface="Calibri" pitchFamily="34" charset="-122"/>
+                <a:cs typeface="Calibri" pitchFamily="34" charset="-120"/>
+              </a:rPr>
+              <a:t>Hours of proven understanding, instead of weeks of silent reading.</a:t>
+            </a:r>
+            <a:endParaRPr lang="en-US" sz="1600" dirty="0"/>
+          </a:p>
+        </p:txBody>
+      </p:sp>
       <p:pic>
         <p:nvPicPr>
-          <p:cNvPr id="2" name="Image 0" descr="E:\ibm-bob-2.0-hackathon\assets\slides\slide-10-summary.jpg">    </p:cNvPr>
+          <p:cNvPr id="4" name="Image 0" descr="E:\ibm-bob-2.0-hackathon\assets\slides\slide-10-summary.jpg">    </p:cNvPr>
           <p:cNvPicPr>
             <a:picLocks noChangeAspect="1"/>
           </p:cNvPicPr>
@@ -1936,8 +2014,8 @@
         </p:blipFill>
         <p:spPr>
           <a:xfrm>
-            <a:off x="6537960" y="0"/>
-            <a:ext cx="5623560" cy="6858000"/>
+            <a:off x="1737360" y="2697480"/>
+            <a:ext cx="8686800" cy="4050792"/>
           </a:xfrm>
           <a:prstGeom prst="rect">
             <a:avLst/>
@@ -1946,112 +2024,14 @@
       </p:pic>
       <p:sp>
         <p:nvSpPr>
-          <p:cNvPr id="3" name="Shape 0"/>
-          <p:cNvSpPr/>
-          <p:nvPr/>
-        </p:nvSpPr>
-        <p:spPr>
-          <a:xfrm>
-            <a:off x="6309360" y="0"/>
-            <a:ext cx="228600" cy="6858000"/>
-          </a:xfrm>
-          <a:prstGeom prst="rect">
-            <a:avLst/>
-          </a:prstGeom>
-          <a:solidFill>
-            <a:srgbClr val="14120F"/>
-          </a:solidFill>
-          <a:ln/>
-        </p:spPr>
-      </p:sp>
-      <p:sp>
-        <p:nvSpPr>
-          <p:cNvPr id="4" name="Text 1"/>
-          <p:cNvSpPr txBox="1"/>
-          <p:nvPr/>
-        </p:nvSpPr>
-        <p:spPr>
-          <a:xfrm>
-            <a:off x="640080" y="2377440"/>
-            <a:ext cx="5486400" cy="914400"/>
-          </a:xfrm>
-          <a:prstGeom prst="rect">
-            <a:avLst/>
-          </a:prstGeom>
-          <a:noFill/>
-          <a:ln/>
-        </p:spPr>
-        <p:txBody>
-          <a:bodyPr wrap="square" lIns="0" tIns="0" rIns="0" bIns="0" rtlCol="0" anchor="ctr"/>
-          <a:lstStyle/>
-          <a:p>
-            <a:pPr indent="0" marL="0">
-              <a:buNone/>
-            </a:pPr>
-            <a:r>
-              <a:rPr lang="en-US" sz="4000" b="1" dirty="0">
-                <a:solidFill>
-                  <a:srgbClr val="4FD3C4"/>
-                </a:solidFill>
-                <a:latin typeface="Century Schoolbook" pitchFamily="34" charset="0"/>
-                <a:ea typeface="Century Schoolbook" pitchFamily="34" charset="-122"/>
-                <a:cs typeface="Century Schoolbook" pitchFamily="34" charset="-120"/>
-              </a:rPr>
-              <a:t>Prove Me Wrong</a:t>
-            </a:r>
-            <a:endParaRPr lang="en-US" sz="4000" dirty="0"/>
-          </a:p>
-        </p:txBody>
-      </p:sp>
-      <p:sp>
-        <p:nvSpPr>
           <p:cNvPr id="5" name="Text 2"/>
           <p:cNvSpPr txBox="1"/>
           <p:nvPr/>
         </p:nvSpPr>
         <p:spPr>
           <a:xfrm>
-            <a:off x="640080" y="3246120"/>
-            <a:ext cx="5394960" cy="822960"/>
-          </a:xfrm>
-          <a:prstGeom prst="rect">
-            <a:avLst/>
-          </a:prstGeom>
-          <a:noFill/>
-          <a:ln/>
-        </p:spPr>
-        <p:txBody>
-          <a:bodyPr wrap="square" lIns="0" tIns="0" rIns="0" bIns="0" rtlCol="0" anchor="ctr"/>
-          <a:lstStyle/>
-          <a:p>
-            <a:pPr indent="0" marL="0">
-              <a:buNone/>
-            </a:pPr>
-            <a:r>
-              <a:rPr lang="en-US" sz="1600" dirty="0">
-                <a:solidFill>
-                  <a:srgbClr val="A49D8B"/>
-                </a:solidFill>
-                <a:latin typeface="Calibri" pitchFamily="34" charset="0"/>
-                <a:ea typeface="Calibri" pitchFamily="34" charset="-122"/>
-                <a:cs typeface="Calibri" pitchFamily="34" charset="-120"/>
-              </a:rPr>
-              <a:t>Hours of proven understanding, instead of weeks of silent reading.</a:t>
-            </a:r>
-            <a:endParaRPr lang="en-US" sz="1600" dirty="0"/>
-          </a:p>
-        </p:txBody>
-      </p:sp>
-      <p:sp>
-        <p:nvSpPr>
-          <p:cNvPr id="6" name="Text 3"/>
-          <p:cNvSpPr txBox="1"/>
-          <p:nvPr/>
-        </p:nvSpPr>
-        <p:spPr>
-          <a:xfrm>
-            <a:off x="640080" y="6126480"/>
-            <a:ext cx="5394960" cy="365760"/>
+            <a:off x="640080" y="6355080"/>
+            <a:ext cx="7315200" cy="365760"/>
           </a:xfrm>
           <a:prstGeom prst="rect">
             <a:avLst/>

</xml_diff>

<commit_message>
Fix pixelation on slide 10 summary screenshot
Recaptured at higher source resolution, and reduced its display size on
the slide (was stretched to 9.5in wide from a ~620px source, now sized
to 6in matching a sensible effective DPI). Same fix philosophy as
slides 1/7: don't force an image bigger than its real detail supports.

Co-Authored-By: Claude Sonnet 5 <noreply@anthropic.com>
</commit_message>
<xml_diff>
--- a/presentation/prove-me-wrong-deck.pptx
+++ b/presentation/prove-me-wrong-deck.pptx
@@ -2014,8 +2014,8 @@
         </p:blipFill>
         <p:spPr>
           <a:xfrm>
-            <a:off x="1737360" y="2697480"/>
-            <a:ext cx="8686800" cy="4050792"/>
+            <a:off x="3337560" y="2697480"/>
+            <a:ext cx="5486400" cy="3520440"/>
           </a:xfrm>
           <a:prstGeom prst="rect">
             <a:avLst/>

</xml_diff>

<commit_message>
Save user's review edits to the deck
Co-Authored-By: Claude Sonnet 5 <noreply@anthropic.com>
</commit_message>
<xml_diff>
--- a/presentation/prove-me-wrong-deck.pptx
+++ b/presentation/prove-me-wrong-deck.pptx
@@ -4,6 +4,9 @@
   <p:sldMasterIdLst>
     <p:sldMasterId id="2147483648" r:id="rId1"/>
   </p:sldMasterIdLst>
+  <p:notesMasterIdLst>
+    <p:notesMasterId r:id="rId12"/>
+  </p:notesMasterIdLst>
   <p:sldIdLst>
     <p:sldId id="256" r:id="rId2"/>
     <p:sldId id="257" r:id="rId3"/>
@@ -16,9 +19,6 @@
     <p:sldId id="264" r:id="rId10"/>
     <p:sldId id="265" r:id="rId11"/>
   </p:sldIdLst>
-  <p:notesMasterIdLst>
-    <p:notesMasterId r:id="rId12"/>
-  </p:notesMasterIdLst>
   <p:sldSz cx="12192000" cy="6858000"/>
   <p:notesSz cx="6858000" cy="12192000"/>
   <p:defaultTextStyle>
@@ -113,6 +113,11 @@
       </a:defRPr>
     </a:lvl9pPr>
   </p:defaultTextStyle>
+  <p:extLst>
+    <p:ext uri="{EFAFB233-063F-42B5-8137-9DF3F51BA10A}">
+      <p15:sldGuideLst xmlns:p15="http://schemas.microsoft.com/office/powerpoint/2012/main"/>
+    </p:ext>
+  </p:extLst>
 </p:presentation>
 </file>
 
@@ -138,234 +143,10 @@
           <a:chExt cx="0" cy="0"/>
         </a:xfrm>
       </p:grpSpPr>
-      <p:sp>
-        <p:nvSpPr>
-          <p:cNvPr id="2" name="Header Placeholder 1"/>
-          <p:cNvSpPr>
-            <a:spLocks noGrp="1"/>
-          </p:cNvSpPr>
-          <p:nvPr>
-            <p:ph type="hdr" sz="quarter"/>
-          </p:nvPr>
-        </p:nvSpPr>
-        <p:spPr>
-          <a:xfrm>
-            <a:off x="0" y="0"/>
-            <a:ext cx="2971800" cy="458788"/>
-          </a:xfrm>
-          <a:prstGeom prst="rect">
-            <a:avLst/>
-          </a:prstGeom>
-        </p:spPr>
-        <p:txBody>
-          <a:bodyPr vert="horz" lIns="91440" tIns="45720" rIns="91440" bIns="45720" rtlCol="0"/>
-          <a:lstStyle>
-            <a:lvl1pPr algn="l">
-              <a:defRPr sz="1200"/>
-            </a:lvl1pPr>
-          </a:lstStyle>
-          <a:p>
-            <a:endParaRPr lang="en-US"/>
-          </a:p>
-        </p:txBody>
-      </p:sp>
-      <p:sp>
-        <p:nvSpPr>
-          <p:cNvPr id="3" name="Date Placeholder 2"/>
-          <p:cNvSpPr>
-            <a:spLocks noGrp="1"/>
-          </p:cNvSpPr>
-          <p:nvPr>
-            <p:ph type="dt" idx="1"/>
-          </p:nvPr>
-        </p:nvSpPr>
-        <p:spPr>
-          <a:xfrm>
-            <a:off x="3884613" y="0"/>
-            <a:ext cx="2971800" cy="458788"/>
-          </a:xfrm>
-          <a:prstGeom prst="rect">
-            <a:avLst/>
-          </a:prstGeom>
-        </p:spPr>
-        <p:txBody>
-          <a:bodyPr vert="horz" lIns="91440" tIns="45720" rIns="91440" bIns="45720" rtlCol="0"/>
-          <a:lstStyle>
-            <a:lvl1pPr algn="r">
-              <a:defRPr sz="1200"/>
-            </a:lvl1pPr>
-          </a:lstStyle>
-          <a:p>
-            <a:fld id="{5282F153-3F37-0F45-9E97-73ACFA13230C}" type="datetimeFigureOut">
-              <a:rPr lang="en-US"/>
-              <a:t>7/23/19</a:t>
-            </a:fld>
-            <a:endParaRPr lang="en-US"/>
-          </a:p>
-        </p:txBody>
-      </p:sp>
-      <p:sp>
-        <p:nvSpPr>
-          <p:cNvPr id="4" name="Slide Image Placeholder 3"/>
-          <p:cNvSpPr>
-            <a:spLocks noGrp="1" noRot="1" noChangeAspect="1"/>
-          </p:cNvSpPr>
-          <p:nvPr>
-            <p:ph type="sldImg" idx="2"/>
-          </p:nvPr>
-        </p:nvSpPr>
-        <p:spPr>
-          <a:xfrm>
-            <a:off x="685800" y="1143000"/>
-            <a:ext cx="5486400" cy="3086100"/>
-          </a:xfrm>
-          <a:prstGeom prst="rect">
-            <a:avLst/>
-          </a:prstGeom>
-          <a:noFill/>
-          <a:ln w="12700">
-            <a:solidFill>
-              <a:prstClr val="black"/>
-            </a:solidFill>
-          </a:ln>
-        </p:spPr>
-        <p:txBody>
-          <a:bodyPr vert="horz" lIns="91440" tIns="45720" rIns="91440" bIns="45720" rtlCol="0" anchor="ctr"/>
-          <a:lstStyle/>
-          <a:p>
-            <a:endParaRPr lang="en-US"/>
-          </a:p>
-        </p:txBody>
-      </p:sp>
-      <p:sp>
-        <p:nvSpPr>
-          <p:cNvPr id="5" name="Notes Placeholder 4"/>
-          <p:cNvSpPr>
-            <a:spLocks noGrp="1"/>
-          </p:cNvSpPr>
-          <p:nvPr>
-            <p:ph type="body" sz="quarter" idx="3"/>
-          </p:nvPr>
-        </p:nvSpPr>
-        <p:spPr>
-          <a:xfrm>
-            <a:off x="685800" y="4400550"/>
-            <a:ext cx="5486400" cy="3600450"/>
-          </a:xfrm>
-          <a:prstGeom prst="rect">
-            <a:avLst/>
-          </a:prstGeom>
-        </p:spPr>
-        <p:txBody>
-          <a:bodyPr vert="horz" lIns="91440" tIns="45720" rIns="91440" bIns="45720" rtlCol="0"/>
-          <a:lstStyle/>
-          <a:p>
-            <a:pPr lvl="0"/>
-            <a:r>
-              <a:rPr lang="en-US"/>
-              <a:t>Click to edit Master text styles</a:t>
-            </a:r>
-          </a:p>
-          <a:p>
-            <a:pPr lvl="1"/>
-            <a:r>
-              <a:rPr lang="en-US"/>
-              <a:t>Second level</a:t>
-            </a:r>
-          </a:p>
-          <a:p>
-            <a:pPr lvl="2"/>
-            <a:r>
-              <a:rPr lang="en-US"/>
-              <a:t>Third level</a:t>
-            </a:r>
-          </a:p>
-          <a:p>
-            <a:pPr lvl="3"/>
-            <a:r>
-              <a:rPr lang="en-US"/>
-              <a:t>Fourth level</a:t>
-            </a:r>
-          </a:p>
-          <a:p>
-            <a:pPr lvl="4"/>
-            <a:r>
-              <a:rPr lang="en-US"/>
-              <a:t>Fifth level</a:t>
-            </a:r>
-          </a:p>
-        </p:txBody>
-      </p:sp>
-      <p:sp>
-        <p:nvSpPr>
-          <p:cNvPr id="6" name="Footer Placeholder 5"/>
-          <p:cNvSpPr>
-            <a:spLocks noGrp="1"/>
-          </p:cNvSpPr>
-          <p:nvPr>
-            <p:ph type="ftr" sz="quarter" idx="4"/>
-          </p:nvPr>
-        </p:nvSpPr>
-        <p:spPr>
-          <a:xfrm>
-            <a:off x="0" y="8685213"/>
-            <a:ext cx="2971800" cy="458787"/>
-          </a:xfrm>
-          <a:prstGeom prst="rect">
-            <a:avLst/>
-          </a:prstGeom>
-        </p:spPr>
-        <p:txBody>
-          <a:bodyPr vert="horz" lIns="91440" tIns="45720" rIns="91440" bIns="45720" rtlCol="0" anchor="b"/>
-          <a:lstStyle>
-            <a:lvl1pPr algn="l">
-              <a:defRPr sz="1200"/>
-            </a:lvl1pPr>
-          </a:lstStyle>
-          <a:p>
-            <a:endParaRPr lang="en-US"/>
-          </a:p>
-        </p:txBody>
-      </p:sp>
-      <p:sp>
-        <p:nvSpPr>
-          <p:cNvPr id="7" name="Slide Number Placeholder 6"/>
-          <p:cNvSpPr>
-            <a:spLocks noGrp="1"/>
-          </p:cNvSpPr>
-          <p:nvPr>
-            <p:ph type="sldNum" sz="quarter" idx="5"/>
-          </p:nvPr>
-        </p:nvSpPr>
-        <p:spPr>
-          <a:xfrm>
-            <a:off x="3884613" y="8685213"/>
-            <a:ext cx="2971800" cy="458787"/>
-          </a:xfrm>
-          <a:prstGeom prst="rect">
-            <a:avLst/>
-          </a:prstGeom>
-        </p:spPr>
-        <p:txBody>
-          <a:bodyPr vert="horz" lIns="91440" tIns="45720" rIns="91440" bIns="45720" rtlCol="0" anchor="b"/>
-          <a:lstStyle>
-            <a:lvl1pPr algn="r">
-              <a:defRPr sz="1200"/>
-            </a:lvl1pPr>
-          </a:lstStyle>
-          <a:p>
-            <a:fld id="{CE5E9CC1-C706-0F49-92D6-E571CC5EEA8F}" type="slidenum">
-              <a:rPr lang="en-US"/>
-              <a:t>‹#›</a:t>
-            </a:fld>
-            <a:endParaRPr lang="en-US"/>
-          </a:p>
-        </p:txBody>
-      </p:sp>
     </p:spTree>
     <p:extLst>
       <p:ext uri="{BB962C8B-B14F-4D97-AF65-F5344CB8AC3E}">
-        <p14:creationId xmlns:p14="http://schemas.microsoft.com/office/powerpoint/2010/main" val="1024086991"/>
+        <p14:creationId xmlns:p14="http://schemas.microsoft.com/office/powerpoint/2010/main" val="3529836214"/>
       </p:ext>
     </p:extLst>
   </p:cSld>
@@ -509,10 +290,6 @@
           <a:bodyPr/>
           <a:lstStyle/>
           <a:p>
-            <a:r>
-              <a:rPr lang="en-US" dirty="0"/>
-              <a:t/>
-            </a:r>
             <a:endParaRPr lang="en-US" dirty="0"/>
           </a:p>
         </p:txBody>
@@ -597,10 +374,6 @@
           <a:bodyPr/>
           <a:lstStyle/>
           <a:p>
-            <a:r>
-              <a:rPr lang="en-US" dirty="0"/>
-              <a:t/>
-            </a:r>
             <a:endParaRPr lang="en-US" dirty="0"/>
           </a:p>
         </p:txBody>
@@ -685,10 +458,6 @@
           <a:bodyPr/>
           <a:lstStyle/>
           <a:p>
-            <a:r>
-              <a:rPr lang="en-US" dirty="0"/>
-              <a:t/>
-            </a:r>
             <a:endParaRPr lang="en-US" dirty="0"/>
           </a:p>
         </p:txBody>
@@ -773,10 +542,6 @@
           <a:bodyPr/>
           <a:lstStyle/>
           <a:p>
-            <a:r>
-              <a:rPr lang="en-US" dirty="0"/>
-              <a:t/>
-            </a:r>
             <a:endParaRPr lang="en-US" dirty="0"/>
           </a:p>
         </p:txBody>
@@ -861,10 +626,6 @@
           <a:bodyPr/>
           <a:lstStyle/>
           <a:p>
-            <a:r>
-              <a:rPr lang="en-US" dirty="0"/>
-              <a:t/>
-            </a:r>
             <a:endParaRPr lang="en-US" dirty="0"/>
           </a:p>
         </p:txBody>
@@ -949,10 +710,6 @@
           <a:bodyPr/>
           <a:lstStyle/>
           <a:p>
-            <a:r>
-              <a:rPr lang="en-US" dirty="0"/>
-              <a:t/>
-            </a:r>
             <a:endParaRPr lang="en-US" dirty="0"/>
           </a:p>
         </p:txBody>
@@ -1037,10 +794,6 @@
           <a:bodyPr/>
           <a:lstStyle/>
           <a:p>
-            <a:r>
-              <a:rPr lang="en-US" dirty="0"/>
-              <a:t/>
-            </a:r>
             <a:endParaRPr lang="en-US" dirty="0"/>
           </a:p>
         </p:txBody>
@@ -1125,10 +878,6 @@
           <a:bodyPr/>
           <a:lstStyle/>
           <a:p>
-            <a:r>
-              <a:rPr lang="en-US" dirty="0"/>
-              <a:t/>
-            </a:r>
             <a:endParaRPr lang="en-US" dirty="0"/>
           </a:p>
         </p:txBody>
@@ -1213,10 +962,6 @@
           <a:bodyPr/>
           <a:lstStyle/>
           <a:p>
-            <a:r>
-              <a:rPr lang="en-US" dirty="0"/>
-              <a:t/>
-            </a:r>
             <a:endParaRPr lang="en-US" dirty="0"/>
           </a:p>
         </p:txBody>
@@ -1301,10 +1046,6 @@
           <a:bodyPr/>
           <a:lstStyle/>
           <a:p>
-            <a:r>
-              <a:rPr lang="en-US" dirty="0"/>
-              <a:t/>
-            </a:r>
             <a:endParaRPr lang="en-US" dirty="0"/>
           </a:p>
         </p:txBody>
@@ -1378,6 +1119,11 @@
 <file path=ppt/slideMasters/slideMaster1.xml><?xml version="1.0" encoding="utf-8"?>
 <p:sldMaster xmlns:a="http://schemas.openxmlformats.org/drawingml/2006/main" xmlns:r="http://schemas.openxmlformats.org/officeDocument/2006/relationships" xmlns:p="http://schemas.openxmlformats.org/presentationml/2006/main">
   <p:cSld>
+    <p:bg>
+      <p:bgRef idx="1001">
+        <a:schemeClr val="bg1"/>
+      </p:bgRef>
+    </p:bg>
     <p:spTree>
       <p:nvGrpSpPr>
         <p:cNvPr id="1" name=""/>
@@ -1660,6 +1406,7 @@
         <a:solidFill>
           <a:srgbClr val="14120F"/>
         </a:solidFill>
+        <a:effectLst/>
       </p:bgPr>
     </p:bg>
     <p:spTree>
@@ -1678,15 +1425,15 @@
       </p:grpSpPr>
       <p:pic>
         <p:nvPicPr>
-          <p:cNvPr id="2" name="Image 0" descr="E:\ibm-bob-2.0-hackathon\assets\cover\cover-image.jpg">    </p:cNvPr>
+          <p:cNvPr id="2" name="Image 0" descr="E:\ibm-bob-2.0-hackathon\assets\cover\cover-image.jpg"/>
           <p:cNvPicPr>
             <a:picLocks noChangeAspect="1"/>
           </p:cNvPicPr>
           <p:nvPr/>
         </p:nvPicPr>
         <p:blipFill>
-          <a:blip r:embed="rId1"/>
-          <a:srcRect l="0" r="0" t="0" b="0"/>
+          <a:blip r:embed="rId3"/>
+          <a:srcRect/>
           <a:stretch/>
         </p:blipFill>
         <p:spPr>
@@ -1740,11 +1487,11 @@
           <a:bodyPr wrap="square" lIns="0" tIns="0" rIns="0" bIns="0" rtlCol="0" anchor="ctr"/>
           <a:lstStyle/>
           <a:p>
-            <a:pPr indent="0" marL="0">
-              <a:buNone/>
-            </a:pPr>
-            <a:r>
-              <a:rPr lang="en-US" sz="1300" b="1" spc="200" kern="0" dirty="0">
+            <a:pPr marL="0" indent="0">
+              <a:buNone/>
+            </a:pPr>
+            <a:r>
+              <a:rPr lang="en-US" sz="1300" b="1" kern="0" spc="200" dirty="0">
                 <a:solidFill>
                   <a:srgbClr val="4FD3C4"/>
                 </a:solidFill>
@@ -1779,7 +1526,7 @@
           <a:bodyPr wrap="square" lIns="0" tIns="0" rIns="0" bIns="0" rtlCol="0" anchor="ctr"/>
           <a:lstStyle/>
           <a:p>
-            <a:pPr indent="0" marL="0">
+            <a:pPr marL="0" indent="0">
               <a:buNone/>
             </a:pPr>
             <a:r>
@@ -1793,9 +1540,6 @@
               </a:rPr>
               <a:t>Prove </a:t>
             </a:r>
-            <a:pPr indent="0" marL="0">
-              <a:buNone/>
-            </a:pPr>
             <a:r>
               <a:rPr lang="en-US" sz="5400" b="1" dirty="0">
                 <a:solidFill>
@@ -1819,7 +1563,7 @@
         </p:nvSpPr>
         <p:spPr>
           <a:xfrm>
-            <a:off x="640080" y="3703320"/>
+            <a:off x="640080" y="3878248"/>
             <a:ext cx="5303520" cy="548640"/>
           </a:xfrm>
           <a:prstGeom prst="rect">
@@ -1832,7 +1576,7 @@
           <a:bodyPr wrap="square" lIns="0" tIns="0" rIns="0" bIns="0" rtlCol="0" anchor="ctr"/>
           <a:lstStyle/>
           <a:p>
-            <a:pPr indent="0" marL="0">
+            <a:pPr marL="0" indent="0">
               <a:buNone/>
             </a:pPr>
             <a:r>
@@ -1871,11 +1615,11 @@
           <a:bodyPr wrap="square" lIns="0" tIns="0" rIns="0" bIns="0" rtlCol="0" anchor="ctr"/>
           <a:lstStyle/>
           <a:p>
-            <a:pPr indent="0" marL="0">
-              <a:buNone/>
-            </a:pPr>
-            <a:r>
-              <a:rPr lang="en-US" sz="1100" spc="100" kern="0" dirty="0">
+            <a:pPr marL="0" indent="0">
+              <a:buNone/>
+            </a:pPr>
+            <a:r>
+              <a:rPr lang="en-US" sz="1100" kern="0" spc="100" dirty="0">
                 <a:solidFill>
                   <a:srgbClr val="A49D8B"/>
                 </a:solidFill>
@@ -1905,6 +1649,7 @@
         <a:solidFill>
           <a:srgbClr val="14120F"/>
         </a:solidFill>
+        <a:effectLst/>
       </p:bgPr>
     </p:bg>
     <p:spTree>
@@ -1942,7 +1687,7 @@
           <a:bodyPr wrap="square" lIns="0" tIns="0" rIns="0" bIns="0" rtlCol="0" anchor="ctr"/>
           <a:lstStyle/>
           <a:p>
-            <a:pPr indent="0" marL="0">
+            <a:pPr marL="0" indent="0">
               <a:buNone/>
             </a:pPr>
             <a:r>
@@ -1981,7 +1726,7 @@
           <a:bodyPr wrap="square" lIns="0" tIns="0" rIns="0" bIns="0" rtlCol="0" anchor="ctr"/>
           <a:lstStyle/>
           <a:p>
-            <a:pPr indent="0" marL="0">
+            <a:pPr marL="0" indent="0">
               <a:buNone/>
             </a:pPr>
             <a:r>
@@ -2001,15 +1746,15 @@
       </p:sp>
       <p:pic>
         <p:nvPicPr>
-          <p:cNvPr id="4" name="Image 0" descr="E:\ibm-bob-2.0-hackathon\assets\slides\slide-10-summary.jpg">    </p:cNvPr>
+          <p:cNvPr id="4" name="Image 0" descr="E:\ibm-bob-2.0-hackathon\assets\slides\slide-10-summary.jpg"/>
           <p:cNvPicPr>
             <a:picLocks noChangeAspect="1"/>
           </p:cNvPicPr>
           <p:nvPr/>
         </p:nvPicPr>
         <p:blipFill>
-          <a:blip r:embed="rId1"/>
-          <a:srcRect l="0" r="0" t="0" b="0"/>
+          <a:blip r:embed="rId3"/>
+          <a:srcRect/>
           <a:stretch/>
         </p:blipFill>
         <p:spPr>
@@ -2043,7 +1788,7 @@
           <a:bodyPr wrap="square" lIns="0" tIns="0" rIns="0" bIns="0" rtlCol="0" anchor="ctr"/>
           <a:lstStyle/>
           <a:p>
-            <a:pPr indent="0" marL="0">
+            <a:pPr marL="0" indent="0">
               <a:buNone/>
             </a:pPr>
             <a:r>
@@ -2077,6 +1822,7 @@
         <a:solidFill>
           <a:srgbClr val="14120F"/>
         </a:solidFill>
+        <a:effectLst/>
       </p:bgPr>
     </p:bg>
     <p:spTree>
@@ -2114,11 +1860,11 @@
           <a:bodyPr wrap="square" lIns="0" tIns="0" rIns="0" bIns="0" rtlCol="0" anchor="ctr"/>
           <a:lstStyle/>
           <a:p>
-            <a:pPr indent="0" marL="0">
-              <a:buNone/>
-            </a:pPr>
-            <a:r>
-              <a:rPr lang="en-US" sz="1200" b="1" spc="200" kern="0" dirty="0">
+            <a:pPr marL="0" indent="0">
+              <a:buNone/>
+            </a:pPr>
+            <a:r>
+              <a:rPr lang="en-US" sz="1200" b="1" kern="0" spc="200" dirty="0">
                 <a:solidFill>
                   <a:srgbClr val="4FD3C4"/>
                 </a:solidFill>
@@ -2134,15 +1880,15 @@
       </p:sp>
       <p:pic>
         <p:nvPicPr>
-          <p:cNvPr id="3" name="Image 0" descr="E:\ibm-bob-2.0-hackathon\assets\slides\slide-02-mia-story.png">    </p:cNvPr>
+          <p:cNvPr id="3" name="Image 0" descr="E:\ibm-bob-2.0-hackathon\assets\slides\slide-02-mia-story.png"/>
           <p:cNvPicPr>
             <a:picLocks noChangeAspect="1"/>
           </p:cNvPicPr>
           <p:nvPr/>
         </p:nvPicPr>
         <p:blipFill>
-          <a:blip r:embed="rId1"/>
-          <a:srcRect l="0" r="0" t="0" b="0"/>
+          <a:blip r:embed="rId3"/>
+          <a:srcRect/>
           <a:stretch/>
         </p:blipFill>
         <p:spPr>
@@ -2176,7 +1922,7 @@
           <a:bodyPr wrap="square" lIns="0" tIns="0" rIns="0" bIns="0" rtlCol="0" anchor="ctr"/>
           <a:lstStyle/>
           <a:p>
-            <a:pPr indent="0" marL="0">
+            <a:pPr marL="0" indent="0">
               <a:buNone/>
             </a:pPr>
             <a:r>
@@ -2215,7 +1961,7 @@
           <a:bodyPr wrap="square" lIns="0" tIns="0" rIns="0" bIns="0" rtlCol="0" anchor="ctr"/>
           <a:lstStyle/>
           <a:p>
-            <a:pPr indent="0" marL="0">
+            <a:pPr marL="0" indent="0">
               <a:lnSpc>
                 <a:spcPct val="130000"/>
               </a:lnSpc>
@@ -2257,7 +2003,7 @@
           <a:bodyPr wrap="square" lIns="0" tIns="0" rIns="0" bIns="0" rtlCol="0" anchor="ctr"/>
           <a:lstStyle/>
           <a:p>
-            <a:pPr indent="0" marL="0">
+            <a:pPr marL="0" indent="0">
               <a:buNone/>
             </a:pPr>
             <a:r>
@@ -2296,7 +2042,7 @@
           <a:bodyPr wrap="square" lIns="0" tIns="0" rIns="0" bIns="0" rtlCol="0" anchor="ctr"/>
           <a:lstStyle/>
           <a:p>
-            <a:pPr algn="r" indent="0" marL="0">
+            <a:pPr marL="0" indent="0" algn="r">
               <a:buNone/>
             </a:pPr>
             <a:r>
@@ -2330,6 +2076,7 @@
         <a:solidFill>
           <a:srgbClr val="14120F"/>
         </a:solidFill>
+        <a:effectLst/>
       </p:bgPr>
     </p:bg>
     <p:spTree>
@@ -2367,11 +2114,11 @@
           <a:bodyPr wrap="square" lIns="0" tIns="0" rIns="0" bIns="0" rtlCol="0" anchor="ctr"/>
           <a:lstStyle/>
           <a:p>
-            <a:pPr indent="0" marL="0">
-              <a:buNone/>
-            </a:pPr>
-            <a:r>
-              <a:rPr lang="en-US" sz="1200" b="1" spc="200" kern="0" dirty="0">
+            <a:pPr marL="0" indent="0">
+              <a:buNone/>
+            </a:pPr>
+            <a:r>
+              <a:rPr lang="en-US" sz="1200" b="1" kern="0" spc="200" dirty="0">
                 <a:solidFill>
                   <a:srgbClr val="4FD3C4"/>
                 </a:solidFill>
@@ -2406,7 +2153,7 @@
           <a:bodyPr wrap="square" lIns="0" tIns="0" rIns="0" bIns="0" rtlCol="0" anchor="ctr"/>
           <a:lstStyle/>
           <a:p>
-            <a:pPr indent="0" marL="0">
+            <a:pPr marL="0" indent="0">
               <a:buNone/>
             </a:pPr>
             <a:r>
@@ -2472,7 +2219,7 @@
           <a:bodyPr wrap="square" lIns="0" tIns="0" rIns="0" bIns="0" rtlCol="0" anchor="ctr"/>
           <a:lstStyle/>
           <a:p>
-            <a:pPr algn="ctr" indent="0" marL="0">
+            <a:pPr marL="0" indent="0" algn="ctr">
               <a:buNone/>
             </a:pPr>
             <a:r>
@@ -2511,7 +2258,7 @@
           <a:bodyPr wrap="square" lIns="0" tIns="0" rIns="0" bIns="0" rtlCol="0" anchor="ctr"/>
           <a:lstStyle/>
           <a:p>
-            <a:pPr algn="ctr" indent="0" marL="0">
+            <a:pPr marL="0" indent="0" algn="ctr">
               <a:buNone/>
             </a:pPr>
             <a:r>
@@ -2577,7 +2324,7 @@
           <a:bodyPr wrap="square" lIns="0" tIns="0" rIns="0" bIns="0" rtlCol="0" anchor="ctr"/>
           <a:lstStyle/>
           <a:p>
-            <a:pPr algn="ctr" indent="0" marL="0">
+            <a:pPr marL="0" indent="0" algn="ctr">
               <a:buNone/>
             </a:pPr>
             <a:r>
@@ -2616,7 +2363,7 @@
           <a:bodyPr wrap="square" lIns="0" tIns="0" rIns="0" bIns="0" rtlCol="0" anchor="ctr"/>
           <a:lstStyle/>
           <a:p>
-            <a:pPr algn="ctr" indent="0" marL="0">
+            <a:pPr marL="0" indent="0" algn="ctr">
               <a:buNone/>
             </a:pPr>
             <a:r>
@@ -2682,7 +2429,7 @@
           <a:bodyPr wrap="square" lIns="0" tIns="0" rIns="0" bIns="0" rtlCol="0" anchor="ctr"/>
           <a:lstStyle/>
           <a:p>
-            <a:pPr algn="ctr" indent="0" marL="0">
+            <a:pPr marL="0" indent="0" algn="ctr">
               <a:buNone/>
             </a:pPr>
             <a:r>
@@ -2721,7 +2468,7 @@
           <a:bodyPr wrap="square" lIns="0" tIns="0" rIns="0" bIns="0" rtlCol="0" anchor="ctr"/>
           <a:lstStyle/>
           <a:p>
-            <a:pPr algn="ctr" indent="0" marL="0">
+            <a:pPr marL="0" indent="0" algn="ctr">
               <a:buNone/>
             </a:pPr>
             <a:r>
@@ -2787,7 +2534,7 @@
           <a:bodyPr wrap="square" lIns="0" tIns="0" rIns="0" bIns="0" rtlCol="0" anchor="ctr"/>
           <a:lstStyle/>
           <a:p>
-            <a:pPr algn="ctr" indent="0" marL="0">
+            <a:pPr marL="0" indent="0" algn="ctr">
               <a:buNone/>
             </a:pPr>
             <a:r>
@@ -2826,7 +2573,7 @@
           <a:bodyPr wrap="square" lIns="0" tIns="0" rIns="0" bIns="0" rtlCol="0" anchor="ctr"/>
           <a:lstStyle/>
           <a:p>
-            <a:pPr algn="ctr" indent="0" marL="0">
+            <a:pPr marL="0" indent="0" algn="ctr">
               <a:buNone/>
             </a:pPr>
             <a:r>
@@ -2865,7 +2612,7 @@
           <a:bodyPr wrap="square" lIns="0" tIns="0" rIns="0" bIns="0" rtlCol="0" anchor="ctr"/>
           <a:lstStyle/>
           <a:p>
-            <a:pPr indent="0" marL="0">
+            <a:pPr marL="0" indent="0">
               <a:buNone/>
             </a:pPr>
             <a:r>
@@ -2904,7 +2651,7 @@
           <a:bodyPr wrap="square" lIns="0" tIns="0" rIns="0" bIns="0" rtlCol="0" anchor="ctr"/>
           <a:lstStyle/>
           <a:p>
-            <a:pPr algn="r" indent="0" marL="0">
+            <a:pPr marL="0" indent="0" algn="r">
               <a:buNone/>
             </a:pPr>
             <a:r>
@@ -2938,6 +2685,7 @@
         <a:solidFill>
           <a:srgbClr val="14120F"/>
         </a:solidFill>
+        <a:effectLst/>
       </p:bgPr>
     </p:bg>
     <p:spTree>
@@ -2975,11 +2723,11 @@
           <a:bodyPr wrap="square" lIns="0" tIns="0" rIns="0" bIns="0" rtlCol="0" anchor="ctr"/>
           <a:lstStyle/>
           <a:p>
-            <a:pPr indent="0" marL="0">
-              <a:buNone/>
-            </a:pPr>
-            <a:r>
-              <a:rPr lang="en-US" sz="1200" b="1" spc="200" kern="0" dirty="0">
+            <a:pPr marL="0" indent="0">
+              <a:buNone/>
+            </a:pPr>
+            <a:r>
+              <a:rPr lang="en-US" sz="1200" b="1" kern="0" spc="200" dirty="0">
                 <a:solidFill>
                   <a:srgbClr val="4FD3C4"/>
                 </a:solidFill>
@@ -3014,7 +2762,7 @@
           <a:bodyPr wrap="square" lIns="0" tIns="0" rIns="0" bIns="0" rtlCol="0" anchor="ctr"/>
           <a:lstStyle/>
           <a:p>
-            <a:pPr indent="0" marL="0">
+            <a:pPr marL="0" indent="0">
               <a:buNone/>
             </a:pPr>
             <a:r>
@@ -3053,7 +2801,7 @@
           <a:bodyPr wrap="square" lIns="0" tIns="0" rIns="0" bIns="0" rtlCol="0" anchor="ctr"/>
           <a:lstStyle/>
           <a:p>
-            <a:pPr indent="0" marL="0">
+            <a:pPr marL="0" indent="0">
               <a:lnSpc>
                 <a:spcPct val="130000"/>
               </a:lnSpc>
@@ -3118,7 +2866,7 @@
           <a:bodyPr wrap="square" lIns="0" tIns="0" rIns="0" bIns="0" rtlCol="0" anchor="ctr"/>
           <a:lstStyle/>
           <a:p>
-            <a:pPr indent="0" marL="0">
+            <a:pPr marL="0" indent="0">
               <a:buNone/>
             </a:pPr>
             <a:r>
@@ -3157,7 +2905,7 @@
           <a:bodyPr wrap="square" lIns="0" tIns="0" rIns="0" bIns="0" rtlCol="0" anchor="ctr"/>
           <a:lstStyle/>
           <a:p>
-            <a:pPr algn="r" indent="0" marL="0">
+            <a:pPr marL="0" indent="0" algn="r">
               <a:buNone/>
             </a:pPr>
             <a:r>
@@ -3191,6 +2939,7 @@
         <a:solidFill>
           <a:srgbClr val="14120F"/>
         </a:solidFill>
+        <a:effectLst/>
       </p:bgPr>
     </p:bg>
     <p:spTree>
@@ -3228,11 +2977,11 @@
           <a:bodyPr wrap="square" lIns="0" tIns="0" rIns="0" bIns="0" rtlCol="0" anchor="ctr"/>
           <a:lstStyle/>
           <a:p>
-            <a:pPr indent="0" marL="0">
-              <a:buNone/>
-            </a:pPr>
-            <a:r>
-              <a:rPr lang="en-US" sz="1200" b="1" spc="200" kern="0" dirty="0">
+            <a:pPr marL="0" indent="0">
+              <a:buNone/>
+            </a:pPr>
+            <a:r>
+              <a:rPr lang="en-US" sz="1200" b="1" kern="0" spc="200" dirty="0">
                 <a:solidFill>
                   <a:srgbClr val="4FD3C4"/>
                 </a:solidFill>
@@ -3267,7 +3016,7 @@
           <a:bodyPr wrap="square" lIns="0" tIns="0" rIns="0" bIns="0" rtlCol="0" anchor="ctr"/>
           <a:lstStyle/>
           <a:p>
-            <a:pPr indent="0" marL="0">
+            <a:pPr marL="0" indent="0">
               <a:buNone/>
             </a:pPr>
             <a:r>
@@ -3287,15 +3036,15 @@
       </p:sp>
       <p:pic>
         <p:nvPicPr>
-          <p:cNvPr id="4" name="Image 0" descr="E:\ibm-bob-2.0-hackathon\assets\slides\slide-05-diagram.png">    </p:cNvPr>
+          <p:cNvPr id="4" name="Image 0" descr="E:\ibm-bob-2.0-hackathon\assets\slides\slide-05-diagram.png"/>
           <p:cNvPicPr>
             <a:picLocks noChangeAspect="1"/>
           </p:cNvPicPr>
           <p:nvPr/>
         </p:nvPicPr>
         <p:blipFill>
-          <a:blip r:embed="rId1"/>
-          <a:srcRect l="0" r="0" t="0" b="0"/>
+          <a:blip r:embed="rId3"/>
+          <a:srcRect/>
           <a:stretch/>
         </p:blipFill>
         <p:spPr>
@@ -3329,7 +3078,7 @@
           <a:bodyPr wrap="square" lIns="0" tIns="0" rIns="0" bIns="0" rtlCol="0" anchor="ctr"/>
           <a:lstStyle/>
           <a:p>
-            <a:pPr algn="r" indent="0" marL="0">
+            <a:pPr marL="0" indent="0" algn="r">
               <a:buNone/>
             </a:pPr>
             <a:r>
@@ -3363,6 +3112,7 @@
         <a:solidFill>
           <a:srgbClr val="14120F"/>
         </a:solidFill>
+        <a:effectLst/>
       </p:bgPr>
     </p:bg>
     <p:spTree>
@@ -3400,11 +3150,11 @@
           <a:bodyPr wrap="square" lIns="0" tIns="0" rIns="0" bIns="0" rtlCol="0" anchor="ctr"/>
           <a:lstStyle/>
           <a:p>
-            <a:pPr indent="0" marL="0">
-              <a:buNone/>
-            </a:pPr>
-            <a:r>
-              <a:rPr lang="en-US" sz="1200" b="1" spc="200" kern="0" dirty="0">
+            <a:pPr marL="0" indent="0">
+              <a:buNone/>
+            </a:pPr>
+            <a:r>
+              <a:rPr lang="en-US" sz="1200" b="1" kern="0" spc="200" dirty="0">
                 <a:solidFill>
                   <a:srgbClr val="4FD3C4"/>
                 </a:solidFill>
@@ -3439,7 +3189,7 @@
           <a:bodyPr wrap="square" lIns="0" tIns="0" rIns="0" bIns="0" rtlCol="0" anchor="ctr"/>
           <a:lstStyle/>
           <a:p>
-            <a:pPr indent="0" marL="0">
+            <a:pPr marL="0" indent="0">
               <a:buNone/>
             </a:pPr>
             <a:r>
@@ -3503,7 +3253,7 @@
           <a:bodyPr wrap="square" lIns="0" tIns="0" rIns="0" bIns="0" rtlCol="0" anchor="ctr"/>
           <a:lstStyle/>
           <a:p>
-            <a:pPr algn="ctr" indent="0" marL="0">
+            <a:pPr marL="0" indent="0" algn="ctr">
               <a:buNone/>
             </a:pPr>
             <a:r>
@@ -3542,7 +3292,7 @@
           <a:bodyPr wrap="square" lIns="0" tIns="0" rIns="0" bIns="0" rtlCol="0" anchor="ctr"/>
           <a:lstStyle/>
           <a:p>
-            <a:pPr indent="0" marL="0">
+            <a:pPr marL="0" indent="0">
               <a:buNone/>
             </a:pPr>
             <a:r>
@@ -3581,7 +3331,7 @@
           <a:bodyPr wrap="square" lIns="0" tIns="0" rIns="0" bIns="0" rtlCol="0" anchor="ctr"/>
           <a:lstStyle/>
           <a:p>
-            <a:pPr indent="0" marL="0">
+            <a:pPr marL="0" indent="0">
               <a:buNone/>
             </a:pPr>
             <a:r>
@@ -3645,7 +3395,7 @@
           <a:bodyPr wrap="square" lIns="0" tIns="0" rIns="0" bIns="0" rtlCol="0" anchor="ctr"/>
           <a:lstStyle/>
           <a:p>
-            <a:pPr algn="ctr" indent="0" marL="0">
+            <a:pPr marL="0" indent="0" algn="ctr">
               <a:buNone/>
             </a:pPr>
             <a:r>
@@ -3684,7 +3434,7 @@
           <a:bodyPr wrap="square" lIns="0" tIns="0" rIns="0" bIns="0" rtlCol="0" anchor="ctr"/>
           <a:lstStyle/>
           <a:p>
-            <a:pPr indent="0" marL="0">
+            <a:pPr marL="0" indent="0">
               <a:buNone/>
             </a:pPr>
             <a:r>
@@ -3723,7 +3473,7 @@
           <a:bodyPr wrap="square" lIns="0" tIns="0" rIns="0" bIns="0" rtlCol="0" anchor="ctr"/>
           <a:lstStyle/>
           <a:p>
-            <a:pPr indent="0" marL="0">
+            <a:pPr marL="0" indent="0">
               <a:buNone/>
             </a:pPr>
             <a:r>
@@ -3787,7 +3537,7 @@
           <a:bodyPr wrap="square" lIns="0" tIns="0" rIns="0" bIns="0" rtlCol="0" anchor="ctr"/>
           <a:lstStyle/>
           <a:p>
-            <a:pPr algn="ctr" indent="0" marL="0">
+            <a:pPr marL="0" indent="0" algn="ctr">
               <a:buNone/>
             </a:pPr>
             <a:r>
@@ -3826,7 +3576,7 @@
           <a:bodyPr wrap="square" lIns="0" tIns="0" rIns="0" bIns="0" rtlCol="0" anchor="ctr"/>
           <a:lstStyle/>
           <a:p>
-            <a:pPr indent="0" marL="0">
+            <a:pPr marL="0" indent="0">
               <a:buNone/>
             </a:pPr>
             <a:r>
@@ -3865,7 +3615,7 @@
           <a:bodyPr wrap="square" lIns="0" tIns="0" rIns="0" bIns="0" rtlCol="0" anchor="ctr"/>
           <a:lstStyle/>
           <a:p>
-            <a:pPr indent="0" marL="0">
+            <a:pPr marL="0" indent="0">
               <a:buNone/>
             </a:pPr>
             <a:r>
@@ -3904,7 +3654,7 @@
           <a:bodyPr wrap="square" lIns="0" tIns="0" rIns="0" bIns="0" rtlCol="0" anchor="ctr"/>
           <a:lstStyle/>
           <a:p>
-            <a:pPr algn="r" indent="0" marL="0">
+            <a:pPr marL="0" indent="0" algn="r">
               <a:buNone/>
             </a:pPr>
             <a:r>
@@ -3938,6 +3688,7 @@
         <a:solidFill>
           <a:srgbClr val="14120F"/>
         </a:solidFill>
+        <a:effectLst/>
       </p:bgPr>
     </p:bg>
     <p:spTree>
@@ -3975,11 +3726,11 @@
           <a:bodyPr wrap="square" lIns="0" tIns="0" rIns="0" bIns="0" rtlCol="0" anchor="ctr"/>
           <a:lstStyle/>
           <a:p>
-            <a:pPr indent="0" marL="0">
-              <a:buNone/>
-            </a:pPr>
-            <a:r>
-              <a:rPr lang="en-US" sz="1200" b="1" spc="200" kern="0" dirty="0">
+            <a:pPr marL="0" indent="0">
+              <a:buNone/>
+            </a:pPr>
+            <a:r>
+              <a:rPr lang="en-US" sz="1200" b="1" kern="0" spc="200" dirty="0">
                 <a:solidFill>
                   <a:srgbClr val="4FD3C4"/>
                 </a:solidFill>
@@ -4014,7 +3765,7 @@
           <a:bodyPr wrap="square" lIns="0" tIns="0" rIns="0" bIns="0" rtlCol="0" anchor="ctr"/>
           <a:lstStyle/>
           <a:p>
-            <a:pPr indent="0" marL="0">
+            <a:pPr marL="0" indent="0">
               <a:buNone/>
             </a:pPr>
             <a:r>
@@ -4034,15 +3785,15 @@
       </p:sp>
       <p:pic>
         <p:nvPicPr>
-          <p:cNvPr id="4" name="Image 0" descr="E:\ibm-bob-2.0-hackathon\assets\slides\slide-07-correction-citations.jpg">    </p:cNvPr>
+          <p:cNvPr id="4" name="Image 0" descr="E:\ibm-bob-2.0-hackathon\assets\slides\slide-07-correction-citations.jpg"/>
           <p:cNvPicPr>
             <a:picLocks noChangeAspect="1"/>
           </p:cNvPicPr>
           <p:nvPr/>
         </p:nvPicPr>
         <p:blipFill>
-          <a:blip r:embed="rId1"/>
-          <a:srcRect l="0" r="0" t="0" b="0"/>
+          <a:blip r:embed="rId3"/>
+          <a:srcRect/>
           <a:stretch/>
         </p:blipFill>
         <p:spPr>
@@ -4076,7 +3827,7 @@
           <a:bodyPr wrap="square" lIns="0" tIns="0" rIns="0" bIns="0" rtlCol="0" anchor="ctr"/>
           <a:lstStyle/>
           <a:p>
-            <a:pPr algn="r" indent="0" marL="0">
+            <a:pPr marL="0" indent="0" algn="r">
               <a:buNone/>
             </a:pPr>
             <a:r>
@@ -4110,6 +3861,7 @@
         <a:solidFill>
           <a:srgbClr val="14120F"/>
         </a:solidFill>
+        <a:effectLst/>
       </p:bgPr>
     </p:bg>
     <p:spTree>
@@ -4147,11 +3899,11 @@
           <a:bodyPr wrap="square" lIns="0" tIns="0" rIns="0" bIns="0" rtlCol="0" anchor="ctr"/>
           <a:lstStyle/>
           <a:p>
-            <a:pPr indent="0" marL="0">
-              <a:buNone/>
-            </a:pPr>
-            <a:r>
-              <a:rPr lang="en-US" sz="1200" b="1" spc="200" kern="0" dirty="0">
+            <a:pPr marL="0" indent="0">
+              <a:buNone/>
+            </a:pPr>
+            <a:r>
+              <a:rPr lang="en-US" sz="1200" b="1" kern="0" spc="200" dirty="0">
                 <a:solidFill>
                   <a:srgbClr val="4FD3C4"/>
                 </a:solidFill>
@@ -4186,7 +3938,7 @@
           <a:bodyPr wrap="square" lIns="0" tIns="0" rIns="0" bIns="0" rtlCol="0" anchor="ctr"/>
           <a:lstStyle/>
           <a:p>
-            <a:pPr indent="0" marL="0">
+            <a:pPr marL="0" indent="0">
               <a:buNone/>
             </a:pPr>
             <a:r>
@@ -4225,7 +3977,7 @@
           <a:bodyPr wrap="square" lIns="0" tIns="0" rIns="0" bIns="0" rtlCol="0" anchor="ctr"/>
           <a:lstStyle/>
           <a:p>
-            <a:pPr indent="0" marL="0">
+            <a:pPr marL="0" indent="0">
               <a:lnSpc>
                 <a:spcPct val="130000"/>
               </a:lnSpc>
@@ -4294,7 +4046,7 @@
           <a:bodyPr wrap="square" lIns="0" tIns="0" rIns="0" bIns="0" rtlCol="0" anchor="ctr"/>
           <a:lstStyle/>
           <a:p>
-            <a:pPr algn="ctr" indent="0" marL="0">
+            <a:pPr marL="0" indent="0" algn="ctr">
               <a:buNone/>
             </a:pPr>
             <a:r>
@@ -4333,7 +4085,7 @@
           <a:bodyPr wrap="square" lIns="0" tIns="0" rIns="0" bIns="0" rtlCol="0" anchor="ctr"/>
           <a:lstStyle/>
           <a:p>
-            <a:pPr algn="ctr" indent="0" marL="0">
+            <a:pPr marL="0" indent="0" algn="ctr">
               <a:buNone/>
             </a:pPr>
             <a:r>
@@ -4395,7 +4147,7 @@
           <a:bodyPr wrap="square" lIns="0" tIns="0" rIns="0" bIns="0" rtlCol="0" anchor="ctr"/>
           <a:lstStyle/>
           <a:p>
-            <a:pPr algn="ctr" indent="0" marL="0">
+            <a:pPr marL="0" indent="0" algn="ctr">
               <a:buNone/>
             </a:pPr>
             <a:r>
@@ -4421,7 +4173,7 @@
         </p:nvSpPr>
         <p:spPr>
           <a:xfrm>
-            <a:off x="7772400" y="5029200"/>
+            <a:off x="7772400" y="5204129"/>
             <a:ext cx="3474720" cy="457200"/>
           </a:xfrm>
           <a:prstGeom prst="rect">
@@ -4434,7 +4186,7 @@
           <a:bodyPr wrap="square" lIns="0" tIns="0" rIns="0" bIns="0" rtlCol="0" anchor="ctr"/>
           <a:lstStyle/>
           <a:p>
-            <a:pPr algn="ctr" indent="0" marL="0">
+            <a:pPr marL="0" indent="0" algn="ctr">
               <a:buNone/>
             </a:pPr>
             <a:r>
@@ -4473,7 +4225,7 @@
           <a:bodyPr wrap="square" lIns="0" tIns="0" rIns="0" bIns="0" rtlCol="0" anchor="ctr"/>
           <a:lstStyle/>
           <a:p>
-            <a:pPr algn="r" indent="0" marL="0">
+            <a:pPr marL="0" indent="0" algn="r">
               <a:buNone/>
             </a:pPr>
             <a:r>
@@ -4507,6 +4259,7 @@
         <a:solidFill>
           <a:srgbClr val="14120F"/>
         </a:solidFill>
+        <a:effectLst/>
       </p:bgPr>
     </p:bg>
     <p:spTree>
@@ -4544,11 +4297,11 @@
           <a:bodyPr wrap="square" lIns="0" tIns="0" rIns="0" bIns="0" rtlCol="0" anchor="ctr"/>
           <a:lstStyle/>
           <a:p>
-            <a:pPr indent="0" marL="0">
-              <a:buNone/>
-            </a:pPr>
-            <a:r>
-              <a:rPr lang="en-US" sz="1200" b="1" spc="200" kern="0" dirty="0">
+            <a:pPr marL="0" indent="0">
+              <a:buNone/>
+            </a:pPr>
+            <a:r>
+              <a:rPr lang="en-US" sz="1200" b="1" kern="0" spc="200" dirty="0">
                 <a:solidFill>
                   <a:srgbClr val="4FD3C4"/>
                 </a:solidFill>
@@ -4583,7 +4336,7 @@
           <a:bodyPr wrap="square" lIns="0" tIns="0" rIns="0" bIns="0" rtlCol="0" anchor="ctr"/>
           <a:lstStyle/>
           <a:p>
-            <a:pPr indent="0" marL="0">
+            <a:pPr marL="0" indent="0">
               <a:buNone/>
             </a:pPr>
             <a:r>
@@ -4649,7 +4402,7 @@
           <a:bodyPr wrap="square" lIns="0" tIns="0" rIns="0" bIns="0" rtlCol="0" anchor="ctr"/>
           <a:lstStyle/>
           <a:p>
-            <a:pPr indent="0" marL="0">
+            <a:pPr marL="0" indent="0">
               <a:buNone/>
             </a:pPr>
             <a:r>
@@ -4710,7 +4463,7 @@
             <a:endParaRPr lang="en-US" sz="1400" dirty="0"/>
           </a:p>
           <a:p>
-            <a:pPr indent="0" marL="0">
+            <a:pPr marL="0" indent="0">
               <a:spcAft>
                 <a:spcPts val="1000"/>
               </a:spcAft>
@@ -4731,7 +4484,7 @@
             <a:endParaRPr lang="en-US" sz="1400" dirty="0"/>
           </a:p>
           <a:p>
-            <a:pPr indent="0" marL="0">
+            <a:pPr marL="0" indent="0">
               <a:spcAft>
                 <a:spcPts val="1000"/>
               </a:spcAft>
@@ -4800,7 +4553,7 @@
           <a:bodyPr wrap="square" lIns="0" tIns="0" rIns="0" bIns="0" rtlCol="0" anchor="ctr"/>
           <a:lstStyle/>
           <a:p>
-            <a:pPr indent="0" marL="0">
+            <a:pPr marL="0" indent="0">
               <a:buNone/>
             </a:pPr>
             <a:r>
@@ -4861,7 +4614,7 @@
             <a:endParaRPr lang="en-US" sz="1400" dirty="0"/>
           </a:p>
           <a:p>
-            <a:pPr indent="0" marL="0">
+            <a:pPr marL="0" indent="0">
               <a:spcAft>
                 <a:spcPts val="1000"/>
               </a:spcAft>
@@ -4882,7 +4635,7 @@
             <a:endParaRPr lang="en-US" sz="1400" dirty="0"/>
           </a:p>
           <a:p>
-            <a:pPr indent="0" marL="0">
+            <a:pPr marL="0" indent="0">
               <a:spcAft>
                 <a:spcPts val="1000"/>
               </a:spcAft>
@@ -4924,7 +4677,7 @@
           <a:bodyPr wrap="square" lIns="0" tIns="0" rIns="0" bIns="0" rtlCol="0" anchor="ctr"/>
           <a:lstStyle/>
           <a:p>
-            <a:pPr algn="r" indent="0" marL="0">
+            <a:pPr marL="0" indent="0" algn="r">
               <a:buNone/>
             </a:pPr>
             <a:r>
@@ -5243,4 +4996,299 @@
     </a:ext>
   </a:extLst>
 </a:theme>
+</file>
+
+<file path=ppt/theme/theme2.xml><?xml version="1.0" encoding="utf-8"?>
+<a:theme xmlns:a="http://schemas.openxmlformats.org/drawingml/2006/main" name="Office Theme">
+  <a:themeElements>
+    <a:clrScheme name="Office">
+      <a:dk1>
+        <a:sysClr val="windowText" lastClr="000000"/>
+      </a:dk1>
+      <a:lt1>
+        <a:sysClr val="window" lastClr="FFFFFF"/>
+      </a:lt1>
+      <a:dk2>
+        <a:srgbClr val="44546A"/>
+      </a:dk2>
+      <a:lt2>
+        <a:srgbClr val="E7E6E6"/>
+      </a:lt2>
+      <a:accent1>
+        <a:srgbClr val="4472C4"/>
+      </a:accent1>
+      <a:accent2>
+        <a:srgbClr val="ED7D31"/>
+      </a:accent2>
+      <a:accent3>
+        <a:srgbClr val="A5A5A5"/>
+      </a:accent3>
+      <a:accent4>
+        <a:srgbClr val="FFC000"/>
+      </a:accent4>
+      <a:accent5>
+        <a:srgbClr val="5B9BD5"/>
+      </a:accent5>
+      <a:accent6>
+        <a:srgbClr val="70AD47"/>
+      </a:accent6>
+      <a:hlink>
+        <a:srgbClr val="0563C1"/>
+      </a:hlink>
+      <a:folHlink>
+        <a:srgbClr val="954F72"/>
+      </a:folHlink>
+    </a:clrScheme>
+    <a:fontScheme name="Office">
+      <a:majorFont>
+        <a:latin typeface="Calibri Light" panose="020F0302020204030204"/>
+        <a:ea typeface=""/>
+        <a:cs typeface=""/>
+        <a:font script="Jpan" typeface="游ゴシック Light"/>
+        <a:font script="Hang" typeface="맑은 고딕"/>
+        <a:font script="Hans" typeface="等线 Light"/>
+        <a:font script="Hant" typeface="新細明體"/>
+        <a:font script="Arab" typeface="Times New Roman"/>
+        <a:font script="Hebr" typeface="Times New Roman"/>
+        <a:font script="Thai" typeface="Angsana New"/>
+        <a:font script="Ethi" typeface="Nyala"/>
+        <a:font script="Beng" typeface="Vrinda"/>
+        <a:font script="Gujr" typeface="Shruti"/>
+        <a:font script="Khmr" typeface="MoolBoran"/>
+        <a:font script="Knda" typeface="Tunga"/>
+        <a:font script="Guru" typeface="Raavi"/>
+        <a:font script="Cans" typeface="Euphemia"/>
+        <a:font script="Cher" typeface="Plantagenet Cherokee"/>
+        <a:font script="Yiii" typeface="Microsoft Yi Baiti"/>
+        <a:font script="Tibt" typeface="Microsoft Himalaya"/>
+        <a:font script="Thaa" typeface="MV Boli"/>
+        <a:font script="Deva" typeface="Mangal"/>
+        <a:font script="Telu" typeface="Gautami"/>
+        <a:font script="Taml" typeface="Latha"/>
+        <a:font script="Syrc" typeface="Estrangelo Edessa"/>
+        <a:font script="Orya" typeface="Kalinga"/>
+        <a:font script="Mlym" typeface="Kartika"/>
+        <a:font script="Laoo" typeface="DokChampa"/>
+        <a:font script="Sinh" typeface="Iskoola Pota"/>
+        <a:font script="Mong" typeface="Mongolian Baiti"/>
+        <a:font script="Viet" typeface="Times New Roman"/>
+        <a:font script="Uigh" typeface="Microsoft Uighur"/>
+        <a:font script="Geor" typeface="Sylfaen"/>
+        <a:font script="Armn" typeface="Arial"/>
+        <a:font script="Bugi" typeface="Leelawadee UI"/>
+        <a:font script="Bopo" typeface="Microsoft JhengHei"/>
+        <a:font script="Java" typeface="Javanese Text"/>
+        <a:font script="Lisu" typeface="Segoe UI"/>
+        <a:font script="Mymr" typeface="Myanmar Text"/>
+        <a:font script="Nkoo" typeface="Ebrima"/>
+        <a:font script="Olck" typeface="Nirmala UI"/>
+        <a:font script="Osma" typeface="Ebrima"/>
+        <a:font script="Phag" typeface="Phagspa"/>
+        <a:font script="Syrn" typeface="Estrangelo Edessa"/>
+        <a:font script="Syrj" typeface="Estrangelo Edessa"/>
+        <a:font script="Syre" typeface="Estrangelo Edessa"/>
+        <a:font script="Sora" typeface="Nirmala UI"/>
+        <a:font script="Tale" typeface="Microsoft Tai Le"/>
+        <a:font script="Talu" typeface="Microsoft New Tai Lue"/>
+        <a:font script="Tfng" typeface="Ebrima"/>
+      </a:majorFont>
+      <a:minorFont>
+        <a:latin typeface="Calibri" panose="020F0502020204030204"/>
+        <a:ea typeface=""/>
+        <a:cs typeface=""/>
+        <a:font script="Jpan" typeface="游ゴシック"/>
+        <a:font script="Hang" typeface="맑은 고딕"/>
+        <a:font script="Hans" typeface="等线"/>
+        <a:font script="Hant" typeface="新細明體"/>
+        <a:font script="Arab" typeface="Arial"/>
+        <a:font script="Hebr" typeface="Arial"/>
+        <a:font script="Thai" typeface="Cordia New"/>
+        <a:font script="Ethi" typeface="Nyala"/>
+        <a:font script="Beng" typeface="Vrinda"/>
+        <a:font script="Gujr" typeface="Shruti"/>
+        <a:font script="Khmr" typeface="DaunPenh"/>
+        <a:font script="Knda" typeface="Tunga"/>
+        <a:font script="Guru" typeface="Raavi"/>
+        <a:font script="Cans" typeface="Euphemia"/>
+        <a:font script="Cher" typeface="Plantagenet Cherokee"/>
+        <a:font script="Yiii" typeface="Microsoft Yi Baiti"/>
+        <a:font script="Tibt" typeface="Microsoft Himalaya"/>
+        <a:font script="Thaa" typeface="MV Boli"/>
+        <a:font script="Deva" typeface="Mangal"/>
+        <a:font script="Telu" typeface="Gautami"/>
+        <a:font script="Taml" typeface="Latha"/>
+        <a:font script="Syrc" typeface="Estrangelo Edessa"/>
+        <a:font script="Orya" typeface="Kalinga"/>
+        <a:font script="Mlym" typeface="Kartika"/>
+        <a:font script="Laoo" typeface="DokChampa"/>
+        <a:font script="Sinh" typeface="Iskoola Pota"/>
+        <a:font script="Mong" typeface="Mongolian Baiti"/>
+        <a:font script="Viet" typeface="Arial"/>
+        <a:font script="Uigh" typeface="Microsoft Uighur"/>
+        <a:font script="Geor" typeface="Sylfaen"/>
+        <a:font script="Armn" typeface="Arial"/>
+        <a:font script="Bugi" typeface="Leelawadee UI"/>
+        <a:font script="Bopo" typeface="Microsoft JhengHei"/>
+        <a:font script="Java" typeface="Javanese Text"/>
+        <a:font script="Lisu" typeface="Segoe UI"/>
+        <a:font script="Mymr" typeface="Myanmar Text"/>
+        <a:font script="Nkoo" typeface="Ebrima"/>
+        <a:font script="Olck" typeface="Nirmala UI"/>
+        <a:font script="Osma" typeface="Ebrima"/>
+        <a:font script="Phag" typeface="Phagspa"/>
+        <a:font script="Syrn" typeface="Estrangelo Edessa"/>
+        <a:font script="Syrj" typeface="Estrangelo Edessa"/>
+        <a:font script="Syre" typeface="Estrangelo Edessa"/>
+        <a:font script="Sora" typeface="Nirmala UI"/>
+        <a:font script="Tale" typeface="Microsoft Tai Le"/>
+        <a:font script="Talu" typeface="Microsoft New Tai Lue"/>
+        <a:font script="Tfng" typeface="Ebrima"/>
+      </a:minorFont>
+    </a:fontScheme>
+    <a:fmtScheme name="Office">
+      <a:fillStyleLst>
+        <a:solidFill>
+          <a:schemeClr val="phClr"/>
+        </a:solidFill>
+        <a:gradFill rotWithShape="1">
+          <a:gsLst>
+            <a:gs pos="0">
+              <a:schemeClr val="phClr">
+                <a:lumMod val="110000"/>
+                <a:satMod val="105000"/>
+                <a:tint val="67000"/>
+              </a:schemeClr>
+            </a:gs>
+            <a:gs pos="50000">
+              <a:schemeClr val="phClr">
+                <a:lumMod val="105000"/>
+                <a:satMod val="103000"/>
+                <a:tint val="73000"/>
+              </a:schemeClr>
+            </a:gs>
+            <a:gs pos="100000">
+              <a:schemeClr val="phClr">
+                <a:lumMod val="105000"/>
+                <a:satMod val="109000"/>
+                <a:tint val="81000"/>
+              </a:schemeClr>
+            </a:gs>
+          </a:gsLst>
+          <a:lin ang="5400000" scaled="0"/>
+        </a:gradFill>
+        <a:gradFill rotWithShape="1">
+          <a:gsLst>
+            <a:gs pos="0">
+              <a:schemeClr val="phClr">
+                <a:satMod val="103000"/>
+                <a:lumMod val="102000"/>
+                <a:tint val="94000"/>
+              </a:schemeClr>
+            </a:gs>
+            <a:gs pos="50000">
+              <a:schemeClr val="phClr">
+                <a:satMod val="110000"/>
+                <a:lumMod val="100000"/>
+                <a:shade val="100000"/>
+              </a:schemeClr>
+            </a:gs>
+            <a:gs pos="100000">
+              <a:schemeClr val="phClr">
+                <a:lumMod val="99000"/>
+                <a:satMod val="120000"/>
+                <a:shade val="78000"/>
+              </a:schemeClr>
+            </a:gs>
+          </a:gsLst>
+          <a:lin ang="5400000" scaled="0"/>
+        </a:gradFill>
+      </a:fillStyleLst>
+      <a:lnStyleLst>
+        <a:ln w="6350" cap="flat" cmpd="sng" algn="ctr">
+          <a:solidFill>
+            <a:schemeClr val="phClr"/>
+          </a:solidFill>
+          <a:prstDash val="solid"/>
+          <a:miter lim="800000"/>
+        </a:ln>
+        <a:ln w="12700" cap="flat" cmpd="sng" algn="ctr">
+          <a:solidFill>
+            <a:schemeClr val="phClr"/>
+          </a:solidFill>
+          <a:prstDash val="solid"/>
+          <a:miter lim="800000"/>
+        </a:ln>
+        <a:ln w="19050" cap="flat" cmpd="sng" algn="ctr">
+          <a:solidFill>
+            <a:schemeClr val="phClr"/>
+          </a:solidFill>
+          <a:prstDash val="solid"/>
+          <a:miter lim="800000"/>
+        </a:ln>
+      </a:lnStyleLst>
+      <a:effectStyleLst>
+        <a:effectStyle>
+          <a:effectLst/>
+        </a:effectStyle>
+        <a:effectStyle>
+          <a:effectLst/>
+        </a:effectStyle>
+        <a:effectStyle>
+          <a:effectLst>
+            <a:outerShdw blurRad="57150" dist="19050" dir="5400000" algn="ctr" rotWithShape="0">
+              <a:srgbClr val="000000">
+                <a:alpha val="63000"/>
+              </a:srgbClr>
+            </a:outerShdw>
+          </a:effectLst>
+        </a:effectStyle>
+      </a:effectStyleLst>
+      <a:bgFillStyleLst>
+        <a:solidFill>
+          <a:schemeClr val="phClr"/>
+        </a:solidFill>
+        <a:solidFill>
+          <a:schemeClr val="phClr">
+            <a:tint val="95000"/>
+            <a:satMod val="170000"/>
+          </a:schemeClr>
+        </a:solidFill>
+        <a:gradFill rotWithShape="1">
+          <a:gsLst>
+            <a:gs pos="0">
+              <a:schemeClr val="phClr">
+                <a:tint val="93000"/>
+                <a:satMod val="150000"/>
+                <a:shade val="98000"/>
+                <a:lumMod val="102000"/>
+              </a:schemeClr>
+            </a:gs>
+            <a:gs pos="50000">
+              <a:schemeClr val="phClr">
+                <a:tint val="98000"/>
+                <a:satMod val="130000"/>
+                <a:shade val="90000"/>
+                <a:lumMod val="103000"/>
+              </a:schemeClr>
+            </a:gs>
+            <a:gs pos="100000">
+              <a:schemeClr val="phClr">
+                <a:shade val="63000"/>
+                <a:satMod val="120000"/>
+              </a:schemeClr>
+            </a:gs>
+          </a:gsLst>
+          <a:lin ang="5400000" scaled="0"/>
+        </a:gradFill>
+      </a:bgFillStyleLst>
+    </a:fmtScheme>
+  </a:themeElements>
+  <a:objectDefaults/>
+  <a:extraClrSchemeLst/>
+  <a:extLst>
+    <a:ext uri="{05A4C25C-085E-4340-85A3-A5531E510DB2}">
+      <thm15:themeFamily xmlns:thm15="http://schemas.microsoft.com/office/thememl/2012/main" name="Office Theme" id="{62F939B6-93AF-4DB8-9C6B-D6C7DFDC589F}" vid="{4A3C46E8-61CC-4603-A589-7422A47A8E4A}"/>
+    </a:ext>
+  </a:extLst>
+</a:theme>
 </file>
</xml_diff>